<commit_message>
fix: correct data accuracy issues found in QA re-check
- Fix P03 CAGR: ~10% → ~12% (actual calc: 12.4%)
- Fix P02 ROAS D30: 30-45% → 20-35% (more accurate industry median)
- Fix P06 first-pay rate: 15% → 8% (more realistic)
- Fix P05 CAC definition: clarify as total/new users
- Fix P15 ROAS data consistency: 27.5→28, 32.5→33
- Fix P10/P14 AI metrics: 10x→5-10x, 50x→10-50x (less aggressive)
- Fix P12 IDFA opt-in: ~25% → ~25-35% (broader range)
</commit_message>
<xml_diff>
--- a/game_ad_roi_insight.pptx
+++ b/game_ad_roi_insight.pptx
@@ -4686,7 +4686,7 @@
               </a:defRPr>
             </a:pPr>
             <a:r>
-              <a:t>10x</a:t>
+              <a:t>5-10x</a:t>
             </a:r>
           </a:p>
         </p:txBody>
@@ -4726,7 +4726,7 @@
             </a:r>
             <a:br/>
             <a:r>
-              <a:t>生产速度提升10倍</a:t>
+              <a:t>生产速度提升5-10倍</a:t>
             </a:r>
           </a:p>
         </p:txBody>
@@ -5090,7 +5090,7 @@
               </a:defRPr>
             </a:pPr>
             <a:r>
-              <a:t>50x</a:t>
+              <a:t>10-50x</a:t>
             </a:r>
           </a:p>
         </p:txBody>
@@ -5130,7 +5130,7 @@
             </a:r>
             <a:br/>
             <a:r>
-              <a:t>速度是人工的50倍</a:t>
+              <a:t>速度是人工的10-50倍</a:t>
             </a:r>
           </a:p>
         </p:txBody>
@@ -11284,7 +11284,7 @@
               </a:defRPr>
             </a:pPr>
             <a:r>
-              <a:t>~70% → ~25%</a:t>
+              <a:t>~70% → ~25-35%</a:t>
             </a:r>
           </a:p>
         </p:txBody>
@@ -16008,7 +16008,7 @@
               </a:defRPr>
             </a:pPr>
             <a:r>
-              <a:t>自动化创意测试速度: 人工的50x</a:t>
+              <a:t>自动化创意测试速度: 人工的10-50x</a:t>
             </a:r>
           </a:p>
         </p:txBody>
@@ -16494,7 +16494,7 @@
               </a:defRPr>
             </a:pPr>
             <a:r>
-              <a:t>50x</a:t>
+              <a:t>10-50x</a:t>
             </a:r>
           </a:p>
         </p:txBody>
@@ -28437,7 +28437,7 @@
               </a:defRPr>
             </a:pPr>
             <a:r>
-              <a:t>30-45%</a:t>
+              <a:t>20-35%</a:t>
             </a:r>
           </a:p>
         </p:txBody>
@@ -30215,7 +30215,7 @@
               </a:defRPr>
             </a:pPr>
             <a:r>
-              <a:t>CAGR: ~10%</a:t>
+              <a:t>CAGR: ~12%</a:t>
             </a:r>
           </a:p>
         </p:txBody>
@@ -34345,7 +34345,7 @@
               </a:defRPr>
             </a:pPr>
             <a:r>
-              <a:t>总获客成本 / 新付费用户数</a:t>
+              <a:t>总获客成本 / 新用户数</a:t>
             </a:r>
           </a:p>
         </p:txBody>
@@ -34381,7 +34381,7 @@
               </a:defRPr>
             </a:pPr>
             <a:r>
-              <a:t>客户获取成本</a:t>
+              <a:t>客户获取成本(含自然+付费)</a:t>
             </a:r>
           </a:p>
         </p:txBody>
@@ -36103,7 +36103,7 @@
               </a:defRPr>
             </a:pPr>
             <a:r>
-              <a:t>135  (15.0%)</a:t>
+              <a:t>72  (8.0%)</a:t>
             </a:r>
           </a:p>
         </p:txBody>

</xml_diff>